<commit_message>
Update presentation files: replace AI Study AssistantF.pptx and remove RAG_v2_Overview.pptx
</commit_message>
<xml_diff>
--- a/AI Study AssistantF.pptx
+++ b/AI Study AssistantF.pptx
@@ -501,19 +501,6 @@
               </a:lnSpc>
               <a:buNone/>
             </a:pPr>
-            <a:r>
-              <a:rPr lang="en" altLang="en-US" sz="15000" b="1" dirty="0">
-                <a:solidFill>
-                  <a:srgbClr val="5C1A1A">
-                    <a:alpha val="3000"/>
-                  </a:srgbClr>
-                </a:solidFill>
-                <a:latin typeface="Plus Jakarta Sans" pitchFamily="34" charset="0"/>
-                <a:ea typeface="Plus Jakarta Sans" pitchFamily="34" charset="-122"/>
-                <a:cs typeface="Plus Jakarta Sans" pitchFamily="34" charset="-120"/>
-              </a:rPr>
-              <a:t>RAG-AI</a:t>
-            </a:r>
             <a:endParaRPr lang="en" sz="15000" dirty="0"/>
           </a:p>
         </p:txBody>
@@ -616,7 +603,7 @@
         </p:nvSpPr>
         <p:spPr>
           <a:xfrm>
-            <a:off x="609600" y="1888331"/>
+            <a:off x="541867" y="1466850"/>
             <a:ext cx="6400800" cy="1714500"/>
           </a:xfrm>
           <a:prstGeom prst="rect">
@@ -943,13 +930,13 @@
   <p:clrMapOvr>
     <a:masterClrMapping/>
   </p:clrMapOvr>
-  <mc:AlternateContent xmlns:mc="http://schemas.openxmlformats.org/markup-compatibility/2006">
-    <mc:Choice xmlns:p159="http://schemas.microsoft.com/office/powerpoint/2015/09/main" Requires="p159">
+  <mc:AlternateContent xmlns:mc="http://schemas.openxmlformats.org/markup-compatibility/2006" xmlns:p159="http://schemas.microsoft.com/office/powerpoint/2015/09/main">
+    <mc:Choice Requires="p159">
       <p:transition xmlns:p14="http://schemas.microsoft.com/office/powerpoint/2010/main" spd="slow" p14:dur="2000">
         <p159:morph option="byObject"/>
       </p:transition>
     </mc:Choice>
-    <mc:Fallback>
+    <mc:Fallback xmlns="">
       <p:transition spd="slow">
         <p:fade/>
       </p:transition>
@@ -8141,7 +8128,7 @@
         <p:spPr>
           <a:xfrm>
             <a:off x="6981825" y="2308473"/>
-            <a:ext cx="1133326" cy="285750"/>
+            <a:ext cx="1772708" cy="285750"/>
           </a:xfrm>
           <a:prstGeom prst="rect">
             <a:avLst/>
@@ -9604,19 +9591,6 @@
               </a:lnSpc>
               <a:buNone/>
             </a:pPr>
-            <a:r>
-              <a:rPr lang="en" altLang="en-US" sz="24000" b="1" kern="0" spc="-1200" dirty="0">
-                <a:solidFill>
-                  <a:srgbClr val="5C1A1A">
-                    <a:alpha val="5000"/>
-                  </a:srgbClr>
-                </a:solidFill>
-                <a:latin typeface="Plus Jakarta Sans" pitchFamily="34" charset="0"/>
-                <a:ea typeface="Plus Jakarta Sans" pitchFamily="34" charset="-122"/>
-                <a:cs typeface="Plus Jakarta Sans" pitchFamily="34" charset="-120"/>
-              </a:rPr>
-              <a:t>DEMO</a:t>
-            </a:r>
             <a:endParaRPr lang="en" sz="24000" dirty="0"/>
           </a:p>
         </p:txBody>
@@ -10164,7 +10138,7 @@
         <p:spPr>
           <a:xfrm>
             <a:off x="7673876" y="3495526"/>
-            <a:ext cx="1583085" cy="219075"/>
+            <a:ext cx="2079724" cy="219075"/>
           </a:xfrm>
           <a:prstGeom prst="rect">
             <a:avLst/>
@@ -10208,7 +10182,7 @@
         <p:spPr>
           <a:xfrm>
             <a:off x="7464326" y="3886051"/>
-            <a:ext cx="3654177" cy="975122"/>
+            <a:ext cx="3762474" cy="975122"/>
           </a:xfrm>
           <a:prstGeom prst="rect">
             <a:avLst/>
@@ -10220,14 +10194,14 @@
           <a:bodyPr wrap="none" lIns="0" tIns="0" rIns="0" bIns="0" rtlCol="0" anchor="t"/>
           <a:lstStyle/>
           <a:p>
-            <a:pPr marL="0" indent="0" algn="l">
+            <a:pPr marL="0" indent="0">
               <a:lnSpc>
                 <a:spcPts val="1920"/>
               </a:lnSpc>
               <a:buNone/>
             </a:pPr>
             <a:r>
-              <a:rPr lang="en" altLang="en-US" sz="1200" dirty="0">
+              <a:rPr lang="en" altLang="en-US" sz="1100" dirty="0">
                 <a:solidFill>
                   <a:srgbClr val="2D2926"/>
                 </a:solidFill>
@@ -10237,17 +10211,17 @@
               </a:rPr>
               <a:t>The project is designed for immediate verification.</a:t>
             </a:r>
-            <a:endParaRPr lang="en" sz="1200" dirty="0"/>
-          </a:p>
-          <a:p>
-            <a:pPr marL="0" indent="0" algn="l">
+            <a:endParaRPr lang="en" sz="1100" dirty="0"/>
+          </a:p>
+          <a:p>
+            <a:pPr marL="0" indent="0">
               <a:lnSpc>
                 <a:spcPts val="1920"/>
               </a:lnSpc>
               <a:buNone/>
             </a:pPr>
             <a:r>
-              <a:rPr lang="en" altLang="en-US" sz="1200" dirty="0">
+              <a:rPr lang="en" altLang="en-US" sz="1100" dirty="0">
                 <a:solidFill>
                   <a:srgbClr val="2D2926"/>
                 </a:solidFill>
@@ -10257,17 +10231,17 @@
               </a:rPr>
               <a:t>Anyone can clone the repository, install</a:t>
             </a:r>
-            <a:endParaRPr lang="en" sz="1200" dirty="0"/>
-          </a:p>
-          <a:p>
-            <a:pPr marL="0" indent="0" algn="l">
+            <a:endParaRPr lang="en" sz="1100" dirty="0"/>
+          </a:p>
+          <a:p>
+            <a:pPr marL="0" indent="0">
               <a:lnSpc>
                 <a:spcPts val="1920"/>
               </a:lnSpc>
               <a:buNone/>
             </a:pPr>
             <a:r>
-              <a:rPr lang="en" altLang="en-US" sz="1200" dirty="0">
+              <a:rPr lang="en" altLang="en-US" sz="1100" dirty="0">
                 <a:solidFill>
                   <a:srgbClr val="2D2926"/>
                 </a:solidFill>
@@ -10277,17 +10251,17 @@
               </a:rPr>
               <a:t>dependencies, and run the environment to validate</a:t>
             </a:r>
-            <a:endParaRPr lang="en" sz="1200" dirty="0"/>
-          </a:p>
-          <a:p>
-            <a:pPr marL="0" indent="0" algn="l">
+            <a:endParaRPr lang="en" sz="1100" dirty="0"/>
+          </a:p>
+          <a:p>
+            <a:pPr marL="0" indent="0">
               <a:lnSpc>
                 <a:spcPts val="1920"/>
               </a:lnSpc>
               <a:buNone/>
             </a:pPr>
             <a:r>
-              <a:rPr lang="en" altLang="en-US" sz="1200" dirty="0">
+              <a:rPr lang="en" altLang="en-US" sz="1100" dirty="0">
                 <a:solidFill>
                   <a:srgbClr val="2D2926"/>
                 </a:solidFill>
@@ -10297,7 +10271,7 @@
               </a:rPr>
               <a:t>the implementation logic and deployment status.</a:t>
             </a:r>
-            <a:endParaRPr lang="en" sz="1200" dirty="0"/>
+            <a:endParaRPr lang="en" sz="1100" dirty="0"/>
           </a:p>
         </p:txBody>
       </p:sp>

</xml_diff>